<commit_message>
feat(pitch-decks): regenerate 50 PPTX files with embedded platform screenshots - Added screenshot slide injection to generate-pptx.cjs - 2 contextual screenshot slides per deck with PNG images embedded - Keyword-matched screenshots: council, decisions, compliance, pulse, graph, dashboard, gateway
</commit_message>
<xml_diff>
--- a/docs/pitch-decks/investor-50/pptx/01-banking.pptx
+++ b/docs/pitch-decks/investor-50/pptx/01-banking.pptx
@@ -13,9 +13,11 @@
     <p:sldId id="261" r:id="rId7"/>
     <p:sldId id="262" r:id="rId8"/>
     <p:sldId id="263" r:id="rId9"/>
+    <p:sldId id="264" r:id="rId10"/>
+    <p:sldId id="265" r:id="rId11"/>
   </p:sldIdLst>
   <p:notesMasterIdLst>
-    <p:notesMasterId r:id="rId10"/>
+    <p:notesMasterId r:id="rId12"/>
   </p:notesMasterIdLst>
   <p:sldSz cx="12188952" cy="6858000"/>
   <p:notesSz cx="6858000" cy="12188952"/>
@@ -551,6 +553,94 @@
 </p:notes>
 </file>
 
+<file path=ppt/notesSlides/notesSlide10.xml><?xml version="1.0" encoding="utf-8"?>
+<p:notes xmlns:a="http://schemas.openxmlformats.org/drawingml/2006/main" xmlns:r="http://schemas.openxmlformats.org/officeDocument/2006/relationships" xmlns:p="http://schemas.openxmlformats.org/presentationml/2006/main">
+  <p:cSld>
+    <p:spTree>
+      <p:nvGrpSpPr>
+        <p:cNvPr id="1" name=""/>
+        <p:cNvGrpSpPr/>
+        <p:nvPr/>
+      </p:nvGrpSpPr>
+      <p:grpSpPr>
+        <a:xfrm>
+          <a:off x="0" y="0"/>
+          <a:ext cx="0" cy="0"/>
+          <a:chOff x="0" y="0"/>
+          <a:chExt cx="0" cy="0"/>
+        </a:xfrm>
+      </p:grpSpPr>
+      <p:sp>
+        <p:nvSpPr>
+          <p:cNvPr id="2" name="Slide Image Placeholder 1"/>
+          <p:cNvSpPr>
+            <a:spLocks noGrp="1" noRot="1" noChangeAspect="1"/>
+          </p:cNvSpPr>
+          <p:nvPr>
+            <p:ph type="sldImg"/>
+          </p:nvPr>
+        </p:nvSpPr>
+        <p:spPr/>
+      </p:sp>
+      <p:sp>
+        <p:nvSpPr>
+          <p:cNvPr id="3" name="Notes Placeholder 2"/>
+          <p:cNvSpPr>
+            <a:spLocks noGrp="1"/>
+          </p:cNvSpPr>
+          <p:nvPr>
+            <p:ph type="body" idx="1"/>
+          </p:nvPr>
+        </p:nvSpPr>
+        <p:spPr/>
+        <p:txBody>
+          <a:bodyPr/>
+          <a:lstStyle/>
+          <a:p>
+            <a:r>
+              <a:rPr lang="en-US" dirty="0"/>
+              <a:t/>
+            </a:r>
+            <a:endParaRPr lang="en-US" dirty="0"/>
+          </a:p>
+        </p:txBody>
+      </p:sp>
+      <p:sp>
+        <p:nvSpPr>
+          <p:cNvPr id="4" name="Slide Number Placeholder 3"/>
+          <p:cNvSpPr>
+            <a:spLocks noGrp="1"/>
+          </p:cNvSpPr>
+          <p:nvPr>
+            <p:ph type="sldNum" sz="quarter" idx="10"/>
+          </p:nvPr>
+        </p:nvSpPr>
+        <p:spPr/>
+        <p:txBody>
+          <a:bodyPr/>
+          <a:lstStyle/>
+          <a:p>
+            <a:fld id="{F7021451-1387-4CA6-816F-3879F97B5CBC}" type="slidenum">
+              <a:rPr lang="en-US"/>
+              <a:t>10</a:t>
+            </a:fld>
+            <a:endParaRPr lang="en-US"/>
+          </a:p>
+        </p:txBody>
+      </p:sp>
+    </p:spTree>
+    <p:extLst>
+      <p:ext uri="{BB962C8B-B14F-4D97-AF65-F5344CB8AC3E}">
+        <p14:creationId xmlns:p14="http://schemas.microsoft.com/office/powerpoint/2010/main" val="1024086991"/>
+      </p:ext>
+    </p:extLst>
+  </p:cSld>
+  <p:clrMapOvr>
+    <a:masterClrMapping/>
+  </p:clrMapOvr>
+</p:notes>
+</file>
+
 <file path=ppt/notesSlides/notesSlide2.xml><?xml version="1.0" encoding="utf-8"?>
 <p:notes xmlns:a="http://schemas.openxmlformats.org/drawingml/2006/main" xmlns:r="http://schemas.openxmlformats.org/officeDocument/2006/relationships" xmlns:p="http://schemas.openxmlformats.org/presentationml/2006/main">
   <p:cSld>
@@ -1149,6 +1239,94 @@
             <a:fld id="{F7021451-1387-4CA6-816F-3879F97B5CBC}" type="slidenum">
               <a:rPr lang="en-US"/>
               <a:t>8</a:t>
+            </a:fld>
+            <a:endParaRPr lang="en-US"/>
+          </a:p>
+        </p:txBody>
+      </p:sp>
+    </p:spTree>
+    <p:extLst>
+      <p:ext uri="{BB962C8B-B14F-4D97-AF65-F5344CB8AC3E}">
+        <p14:creationId xmlns:p14="http://schemas.microsoft.com/office/powerpoint/2010/main" val="1024086991"/>
+      </p:ext>
+    </p:extLst>
+  </p:cSld>
+  <p:clrMapOvr>
+    <a:masterClrMapping/>
+  </p:clrMapOvr>
+</p:notes>
+</file>
+
+<file path=ppt/notesSlides/notesSlide9.xml><?xml version="1.0" encoding="utf-8"?>
+<p:notes xmlns:a="http://schemas.openxmlformats.org/drawingml/2006/main" xmlns:r="http://schemas.openxmlformats.org/officeDocument/2006/relationships" xmlns:p="http://schemas.openxmlformats.org/presentationml/2006/main">
+  <p:cSld>
+    <p:spTree>
+      <p:nvGrpSpPr>
+        <p:cNvPr id="1" name=""/>
+        <p:cNvGrpSpPr/>
+        <p:nvPr/>
+      </p:nvGrpSpPr>
+      <p:grpSpPr>
+        <a:xfrm>
+          <a:off x="0" y="0"/>
+          <a:ext cx="0" cy="0"/>
+          <a:chOff x="0" y="0"/>
+          <a:chExt cx="0" cy="0"/>
+        </a:xfrm>
+      </p:grpSpPr>
+      <p:sp>
+        <p:nvSpPr>
+          <p:cNvPr id="2" name="Slide Image Placeholder 1"/>
+          <p:cNvSpPr>
+            <a:spLocks noGrp="1" noRot="1" noChangeAspect="1"/>
+          </p:cNvSpPr>
+          <p:nvPr>
+            <p:ph type="sldImg"/>
+          </p:nvPr>
+        </p:nvSpPr>
+        <p:spPr/>
+      </p:sp>
+      <p:sp>
+        <p:nvSpPr>
+          <p:cNvPr id="3" name="Notes Placeholder 2"/>
+          <p:cNvSpPr>
+            <a:spLocks noGrp="1"/>
+          </p:cNvSpPr>
+          <p:nvPr>
+            <p:ph type="body" idx="1"/>
+          </p:nvPr>
+        </p:nvSpPr>
+        <p:spPr/>
+        <p:txBody>
+          <a:bodyPr/>
+          <a:lstStyle/>
+          <a:p>
+            <a:r>
+              <a:rPr lang="en-US" dirty="0"/>
+              <a:t/>
+            </a:r>
+            <a:endParaRPr lang="en-US" dirty="0"/>
+          </a:p>
+        </p:txBody>
+      </p:sp>
+      <p:sp>
+        <p:nvSpPr>
+          <p:cNvPr id="4" name="Slide Number Placeholder 3"/>
+          <p:cNvSpPr>
+            <a:spLocks noGrp="1"/>
+          </p:cNvSpPr>
+          <p:nvPr>
+            <p:ph type="sldNum" sz="quarter" idx="10"/>
+          </p:nvPr>
+        </p:nvSpPr>
+        <p:spPr/>
+        <p:txBody>
+          <a:bodyPr/>
+          <a:lstStyle/>
+          <a:p>
+            <a:fld id="{F7021451-1387-4CA6-816F-3879F97B5CBC}" type="slidenum">
+              <a:rPr lang="en-US"/>
+              <a:t>9</a:t>
             </a:fld>
             <a:endParaRPr lang="en-US"/>
           </a:p>
@@ -1817,6 +1995,522 @@
 </p:sld>
 </file>
 
+<file path=ppt/slides/slide10.xml><?xml version="1.0" encoding="utf-8"?>
+<p:sld xmlns:a="http://schemas.openxmlformats.org/drawingml/2006/main" xmlns:r="http://schemas.openxmlformats.org/officeDocument/2006/relationships" xmlns:p="http://schemas.openxmlformats.org/presentationml/2006/main">
+  <p:cSld name="Slide 10">
+    <p:bg>
+      <p:bgPr>
+        <a:solidFill>
+          <a:srgbClr val="0A0E1A"/>
+        </a:solidFill>
+      </p:bgPr>
+    </p:bg>
+    <p:spTree>
+      <p:nvGrpSpPr>
+        <p:cNvPr id="1" name=""/>
+        <p:cNvGrpSpPr/>
+        <p:nvPr/>
+      </p:nvGrpSpPr>
+      <p:grpSpPr>
+        <a:xfrm>
+          <a:off x="0" y="0"/>
+          <a:ext cx="0" cy="0"/>
+          <a:chOff x="0" y="0"/>
+          <a:chExt cx="0" cy="0"/>
+        </a:xfrm>
+      </p:grpSpPr>
+      <p:sp>
+        <p:nvSpPr>
+          <p:cNvPr id="2" name="Text 0"/>
+          <p:cNvSpPr/>
+          <p:nvPr/>
+        </p:nvSpPr>
+        <p:spPr>
+          <a:xfrm>
+            <a:off x="457200" y="274320"/>
+            <a:ext cx="2743200" cy="274320"/>
+          </a:xfrm>
+          <a:prstGeom prst="rect">
+            <a:avLst/>
+          </a:prstGeom>
+          <a:noFill/>
+          <a:ln/>
+        </p:spPr>
+        <p:txBody>
+          <a:bodyPr wrap="square" rtlCol="0" anchor="ctr"/>
+          <a:lstStyle/>
+          <a:p>
+            <a:pPr indent="0" marL="0">
+              <a:buNone/>
+            </a:pPr>
+            <a:r>
+              <a:rPr lang="en-US" sz="1000" b="1" dirty="0">
+                <a:solidFill>
+                  <a:srgbClr val="D4AF37"/>
+                </a:solidFill>
+              </a:rPr>
+              <a:t>DATACENDIA</a:t>
+            </a:r>
+            <a:endParaRPr lang="en-US" sz="1000" dirty="0"/>
+          </a:p>
+        </p:txBody>
+      </p:sp>
+      <p:sp>
+        <p:nvSpPr>
+          <p:cNvPr id="3" name="Text 1"/>
+          <p:cNvSpPr/>
+          <p:nvPr/>
+        </p:nvSpPr>
+        <p:spPr>
+          <a:xfrm>
+            <a:off x="457200" y="1828800"/>
+            <a:ext cx="10972800" cy="274320"/>
+          </a:xfrm>
+          <a:prstGeom prst="rect">
+            <a:avLst/>
+          </a:prstGeom>
+          <a:noFill/>
+          <a:ln/>
+        </p:spPr>
+        <p:txBody>
+          <a:bodyPr wrap="square" rtlCol="0" anchor="ctr"/>
+          <a:lstStyle/>
+          <a:p>
+            <a:pPr algn="ctr" indent="0" marL="0">
+              <a:buNone/>
+            </a:pPr>
+            <a:r>
+              <a:rPr lang="en-US" sz="1100" dirty="0">
+                <a:solidFill>
+                  <a:srgbClr val="D4AF37"/>
+                </a:solidFill>
+              </a:rPr>
+              <a:t>NEXT STEPS</a:t>
+            </a:r>
+            <a:endParaRPr lang="en-US" sz="1100" dirty="0"/>
+          </a:p>
+        </p:txBody>
+      </p:sp>
+      <p:sp>
+        <p:nvSpPr>
+          <p:cNvPr id="4" name="Text 2"/>
+          <p:cNvSpPr/>
+          <p:nvPr/>
+        </p:nvSpPr>
+        <p:spPr>
+          <a:xfrm>
+            <a:off x="457200" y="2286000"/>
+            <a:ext cx="10972800" cy="731520"/>
+          </a:xfrm>
+          <a:prstGeom prst="rect">
+            <a:avLst/>
+          </a:prstGeom>
+          <a:noFill/>
+          <a:ln/>
+        </p:spPr>
+        <p:txBody>
+          <a:bodyPr wrap="square" rtlCol="0" anchor="ctr"/>
+          <a:lstStyle/>
+          <a:p>
+            <a:pPr algn="ctr" indent="0" marL="0">
+              <a:buNone/>
+            </a:pPr>
+            <a:r>
+              <a:rPr lang="en-US" sz="3600" b="1" dirty="0">
+                <a:solidFill>
+                  <a:srgbClr val="FFFFFF"/>
+                </a:solidFill>
+              </a:rPr>
+              <a:t>Let’s Talk</a:t>
+            </a:r>
+            <a:endParaRPr lang="en-US" sz="3600" dirty="0"/>
+          </a:p>
+        </p:txBody>
+      </p:sp>
+      <p:sp>
+        <p:nvSpPr>
+          <p:cNvPr id="5" name="Text 3"/>
+          <p:cNvSpPr/>
+          <p:nvPr/>
+        </p:nvSpPr>
+        <p:spPr>
+          <a:xfrm>
+            <a:off x="1371600" y="3200400"/>
+            <a:ext cx="9144000" cy="457200"/>
+          </a:xfrm>
+          <a:prstGeom prst="rect">
+            <a:avLst/>
+          </a:prstGeom>
+          <a:noFill/>
+          <a:ln/>
+        </p:spPr>
+        <p:txBody>
+          <a:bodyPr wrap="square" rtlCol="0" anchor="ctr"/>
+          <a:lstStyle/>
+          <a:p>
+            <a:pPr algn="ctr" indent="0" marL="0">
+              <a:buNone/>
+            </a:pPr>
+            <a:r>
+              <a:rPr lang="en-US" sz="1400" dirty="0">
+                <a:solidFill>
+                  <a:srgbClr val="8B8FA3"/>
+                </a:solidFill>
+              </a:rPr>
+              <a:t>AI Governance for Regulated Financial Institutions</a:t>
+            </a:r>
+            <a:endParaRPr lang="en-US" sz="1400" dirty="0"/>
+          </a:p>
+        </p:txBody>
+      </p:sp>
+      <p:sp>
+        <p:nvSpPr>
+          <p:cNvPr id="6" name="Shape 4"/>
+          <p:cNvSpPr/>
+          <p:nvPr/>
+        </p:nvSpPr>
+        <p:spPr>
+          <a:xfrm>
+            <a:off x="2286000" y="3931920"/>
+            <a:ext cx="1828800" cy="457200"/>
+          </a:xfrm>
+          <a:prstGeom prst="roundRect">
+            <a:avLst>
+              <a:gd name="adj" fmla="val 10000"/>
+            </a:avLst>
+          </a:prstGeom>
+          <a:solidFill>
+            <a:srgbClr val="141825"/>
+          </a:solidFill>
+          <a:ln/>
+        </p:spPr>
+      </p:sp>
+      <p:sp>
+        <p:nvSpPr>
+          <p:cNvPr id="7" name="Text 5"/>
+          <p:cNvSpPr/>
+          <p:nvPr/>
+        </p:nvSpPr>
+        <p:spPr>
+          <a:xfrm>
+            <a:off x="2286000" y="3931920"/>
+            <a:ext cx="1828800" cy="457200"/>
+          </a:xfrm>
+          <a:prstGeom prst="rect">
+            <a:avLst/>
+          </a:prstGeom>
+          <a:noFill/>
+          <a:ln/>
+        </p:spPr>
+        <p:txBody>
+          <a:bodyPr wrap="square" rtlCol="0" anchor="ctr"/>
+          <a:lstStyle/>
+          <a:p>
+            <a:pPr algn="ctr" indent="0" marL="0">
+              <a:buNone/>
+            </a:pPr>
+            <a:r>
+              <a:rPr lang="en-US" sz="1100" b="1" dirty="0">
+                <a:solidFill>
+                  <a:srgbClr val="D4AF37"/>
+                </a:solidFill>
+              </a:rPr>
+              <a:t>Schedule Deep Dive</a:t>
+            </a:r>
+            <a:endParaRPr lang="en-US" sz="1100" dirty="0"/>
+          </a:p>
+        </p:txBody>
+      </p:sp>
+      <p:sp>
+        <p:nvSpPr>
+          <p:cNvPr id="8" name="Shape 6"/>
+          <p:cNvSpPr/>
+          <p:nvPr/>
+        </p:nvSpPr>
+        <p:spPr>
+          <a:xfrm>
+            <a:off x="4297680" y="3931920"/>
+            <a:ext cx="1828800" cy="457200"/>
+          </a:xfrm>
+          <a:prstGeom prst="roundRect">
+            <a:avLst>
+              <a:gd name="adj" fmla="val 10000"/>
+            </a:avLst>
+          </a:prstGeom>
+          <a:solidFill>
+            <a:srgbClr val="141825"/>
+          </a:solidFill>
+          <a:ln/>
+        </p:spPr>
+      </p:sp>
+      <p:sp>
+        <p:nvSpPr>
+          <p:cNvPr id="9" name="Text 7"/>
+          <p:cNvSpPr/>
+          <p:nvPr/>
+        </p:nvSpPr>
+        <p:spPr>
+          <a:xfrm>
+            <a:off x="4297680" y="3931920"/>
+            <a:ext cx="1828800" cy="457200"/>
+          </a:xfrm>
+          <a:prstGeom prst="rect">
+            <a:avLst/>
+          </a:prstGeom>
+          <a:noFill/>
+          <a:ln/>
+        </p:spPr>
+        <p:txBody>
+          <a:bodyPr wrap="square" rtlCol="0" anchor="ctr"/>
+          <a:lstStyle/>
+          <a:p>
+            <a:pPr algn="ctr" indent="0" marL="0">
+              <a:buNone/>
+            </a:pPr>
+            <a:r>
+              <a:rPr lang="en-US" sz="1100" b="1" dirty="0">
+                <a:solidFill>
+                  <a:srgbClr val="D4AF37"/>
+                </a:solidFill>
+              </a:rPr>
+              <a:t>Technical Demo</a:t>
+            </a:r>
+            <a:endParaRPr lang="en-US" sz="1100" dirty="0"/>
+          </a:p>
+        </p:txBody>
+      </p:sp>
+      <p:sp>
+        <p:nvSpPr>
+          <p:cNvPr id="10" name="Shape 8"/>
+          <p:cNvSpPr/>
+          <p:nvPr/>
+        </p:nvSpPr>
+        <p:spPr>
+          <a:xfrm>
+            <a:off x="6309360" y="3931920"/>
+            <a:ext cx="1828800" cy="457200"/>
+          </a:xfrm>
+          <a:prstGeom prst="roundRect">
+            <a:avLst>
+              <a:gd name="adj" fmla="val 10000"/>
+            </a:avLst>
+          </a:prstGeom>
+          <a:solidFill>
+            <a:srgbClr val="141825"/>
+          </a:solidFill>
+          <a:ln/>
+        </p:spPr>
+      </p:sp>
+      <p:sp>
+        <p:nvSpPr>
+          <p:cNvPr id="11" name="Text 9"/>
+          <p:cNvSpPr/>
+          <p:nvPr/>
+        </p:nvSpPr>
+        <p:spPr>
+          <a:xfrm>
+            <a:off x="6309360" y="3931920"/>
+            <a:ext cx="1828800" cy="457200"/>
+          </a:xfrm>
+          <a:prstGeom prst="rect">
+            <a:avLst/>
+          </a:prstGeom>
+          <a:noFill/>
+          <a:ln/>
+        </p:spPr>
+        <p:txBody>
+          <a:bodyPr wrap="square" rtlCol="0" anchor="ctr"/>
+          <a:lstStyle/>
+          <a:p>
+            <a:pPr algn="ctr" indent="0" marL="0">
+              <a:buNone/>
+            </a:pPr>
+            <a:r>
+              <a:rPr lang="en-US" sz="1100" b="1" dirty="0">
+                <a:solidFill>
+                  <a:srgbClr val="D4AF37"/>
+                </a:solidFill>
+              </a:rPr>
+              <a:t>Data Room Access</a:t>
+            </a:r>
+            <a:endParaRPr lang="en-US" sz="1100" dirty="0"/>
+          </a:p>
+        </p:txBody>
+      </p:sp>
+      <p:sp>
+        <p:nvSpPr>
+          <p:cNvPr id="12" name="Shape 10"/>
+          <p:cNvSpPr/>
+          <p:nvPr/>
+        </p:nvSpPr>
+        <p:spPr>
+          <a:xfrm>
+            <a:off x="8321040" y="3931920"/>
+            <a:ext cx="1828800" cy="457200"/>
+          </a:xfrm>
+          <a:prstGeom prst="roundRect">
+            <a:avLst>
+              <a:gd name="adj" fmla="val 10000"/>
+            </a:avLst>
+          </a:prstGeom>
+          <a:solidFill>
+            <a:srgbClr val="D4AF37"/>
+          </a:solidFill>
+          <a:ln/>
+        </p:spPr>
+      </p:sp>
+      <p:sp>
+        <p:nvSpPr>
+          <p:cNvPr id="13" name="Text 11"/>
+          <p:cNvSpPr/>
+          <p:nvPr/>
+        </p:nvSpPr>
+        <p:spPr>
+          <a:xfrm>
+            <a:off x="8321040" y="3931920"/>
+            <a:ext cx="1828800" cy="457200"/>
+          </a:xfrm>
+          <a:prstGeom prst="rect">
+            <a:avLst/>
+          </a:prstGeom>
+          <a:noFill/>
+          <a:ln/>
+        </p:spPr>
+        <p:txBody>
+          <a:bodyPr wrap="square" rtlCol="0" anchor="ctr"/>
+          <a:lstStyle/>
+          <a:p>
+            <a:pPr algn="ctr" indent="0" marL="0">
+              <a:buNone/>
+            </a:pPr>
+            <a:r>
+              <a:rPr lang="en-US" sz="1100" b="1" dirty="0">
+                <a:solidFill>
+                  <a:srgbClr val="0A0E1A"/>
+                </a:solidFill>
+              </a:rPr>
+              <a:t>Try Live Demo →</a:t>
+            </a:r>
+            <a:endParaRPr lang="en-US" sz="1100" dirty="0"/>
+          </a:p>
+        </p:txBody>
+      </p:sp>
+      <p:sp>
+        <p:nvSpPr>
+          <p:cNvPr id="14" name="Text 12"/>
+          <p:cNvSpPr/>
+          <p:nvPr/>
+        </p:nvSpPr>
+        <p:spPr>
+          <a:xfrm>
+            <a:off x="1828800" y="5029200"/>
+            <a:ext cx="8229600" cy="365760"/>
+          </a:xfrm>
+          <a:prstGeom prst="rect">
+            <a:avLst/>
+          </a:prstGeom>
+          <a:noFill/>
+          <a:ln/>
+        </p:spPr>
+        <p:txBody>
+          <a:bodyPr wrap="square" rtlCol="0" anchor="ctr"/>
+          <a:lstStyle/>
+          <a:p>
+            <a:pPr algn="ctr" indent="0" marL="0">
+              <a:buNone/>
+            </a:pPr>
+            <a:r>
+              <a:rPr lang="en-US" sz="1200" dirty="0">
+                <a:solidFill>
+                  <a:srgbClr val="8B8FA3"/>
+                </a:solidFill>
+              </a:rPr>
+              <a:t>contact@datacendia.com | datacendia.com</a:t>
+            </a:r>
+            <a:endParaRPr lang="en-US" sz="1200" dirty="0"/>
+          </a:p>
+        </p:txBody>
+      </p:sp>
+      <p:sp>
+        <p:nvSpPr>
+          <p:cNvPr id="15" name="Text 13"/>
+          <p:cNvSpPr/>
+          <p:nvPr/>
+        </p:nvSpPr>
+        <p:spPr>
+          <a:xfrm>
+            <a:off x="457200" y="6400800"/>
+            <a:ext cx="3657600" cy="274320"/>
+          </a:xfrm>
+          <a:prstGeom prst="rect">
+            <a:avLst/>
+          </a:prstGeom>
+          <a:noFill/>
+          <a:ln/>
+        </p:spPr>
+        <p:txBody>
+          <a:bodyPr wrap="square" rtlCol="0" anchor="ctr"/>
+          <a:lstStyle/>
+          <a:p>
+            <a:pPr indent="0" marL="0">
+              <a:buNone/>
+            </a:pPr>
+            <a:r>
+              <a:rPr lang="en-US" sz="800" dirty="0">
+                <a:solidFill>
+                  <a:srgbClr val="8B8FA3"/>
+                </a:solidFill>
+              </a:rPr>
+              <a:t>© 2024-2026 Datacendia, LLC</a:t>
+            </a:r>
+            <a:endParaRPr lang="en-US" sz="800" dirty="0"/>
+          </a:p>
+        </p:txBody>
+      </p:sp>
+      <p:sp>
+        <p:nvSpPr>
+          <p:cNvPr id="16" name="Text 14"/>
+          <p:cNvSpPr/>
+          <p:nvPr/>
+        </p:nvSpPr>
+        <p:spPr>
+          <a:xfrm>
+            <a:off x="8229600" y="6400800"/>
+            <a:ext cx="3657600" cy="274320"/>
+          </a:xfrm>
+          <a:prstGeom prst="rect">
+            <a:avLst/>
+          </a:prstGeom>
+          <a:noFill/>
+          <a:ln/>
+        </p:spPr>
+        <p:txBody>
+          <a:bodyPr wrap="square" rtlCol="0" anchor="ctr"/>
+          <a:lstStyle/>
+          <a:p>
+            <a:pPr algn="r" indent="0" marL="0">
+              <a:buNone/>
+            </a:pPr>
+            <a:r>
+              <a:rPr lang="en-US" sz="800" dirty="0">
+                <a:solidFill>
+                  <a:srgbClr val="8B8FA3"/>
+                </a:solidFill>
+              </a:rPr>
+              <a:t>datacendia.com</a:t>
+            </a:r>
+            <a:endParaRPr lang="en-US" sz="800" dirty="0"/>
+          </a:p>
+        </p:txBody>
+      </p:sp>
+    </p:spTree>
+  </p:cSld>
+  <p:clrMapOvr>
+    <a:masterClrMapping/>
+  </p:clrMapOvr>
+</p:sld>
+</file>
+
 <file path=ppt/slides/slide2.xml><?xml version="1.0" encoding="utf-8"?>
 <p:sld xmlns:a="http://schemas.openxmlformats.org/drawingml/2006/main" xmlns:r="http://schemas.openxmlformats.org/officeDocument/2006/relationships" xmlns:p="http://schemas.openxmlformats.org/presentationml/2006/main">
   <p:cSld name="Slide 2">
@@ -4581,20 +5275,56 @@
         </p:nvSpPr>
         <p:spPr>
           <a:xfrm>
-            <a:off x="457200" y="1828800"/>
-            <a:ext cx="10972800" cy="274320"/>
-          </a:xfrm>
-          <a:prstGeom prst="rect">
-            <a:avLst/>
-          </a:prstGeom>
-          <a:noFill/>
-          <a:ln/>
-        </p:spPr>
-        <p:txBody>
-          <a:bodyPr wrap="square" rtlCol="0" anchor="ctr"/>
-          <a:lstStyle/>
-          <a:p>
-            <a:pPr algn="ctr" indent="0" marL="0">
+            <a:off x="8229600" y="274320"/>
+            <a:ext cx="3657600" cy="274320"/>
+          </a:xfrm>
+          <a:prstGeom prst="rect">
+            <a:avLst/>
+          </a:prstGeom>
+          <a:noFill/>
+          <a:ln/>
+        </p:spPr>
+        <p:txBody>
+          <a:bodyPr wrap="square" rtlCol="0" anchor="ctr"/>
+          <a:lstStyle/>
+          <a:p>
+            <a:pPr algn="r" indent="0" marL="0">
+              <a:buNone/>
+            </a:pPr>
+            <a:r>
+              <a:rPr lang="en-US" sz="800" dirty="0">
+                <a:solidFill>
+                  <a:srgbClr val="8B8FA3"/>
+                </a:solidFill>
+              </a:rPr>
+              <a:t>PLATFORM PROOF</a:t>
+            </a:r>
+            <a:endParaRPr lang="en-US" sz="800" dirty="0"/>
+          </a:p>
+        </p:txBody>
+      </p:sp>
+      <p:sp>
+        <p:nvSpPr>
+          <p:cNvPr id="4" name="Text 2"/>
+          <p:cNvSpPr/>
+          <p:nvPr/>
+        </p:nvSpPr>
+        <p:spPr>
+          <a:xfrm>
+            <a:off x="731520" y="1097280"/>
+            <a:ext cx="4114800" cy="274320"/>
+          </a:xfrm>
+          <a:prstGeom prst="rect">
+            <a:avLst/>
+          </a:prstGeom>
+          <a:noFill/>
+          <a:ln/>
+        </p:spPr>
+        <p:txBody>
+          <a:bodyPr wrap="square" rtlCol="0" anchor="ctr"/>
+          <a:lstStyle/>
+          <a:p>
+            <a:pPr indent="0" marL="0">
               <a:buNone/>
             </a:pPr>
             <a:r>
@@ -4603,7 +5333,7 @@
                   <a:srgbClr val="D4AF37"/>
                 </a:solidFill>
               </a:rPr>
-              <a:t>NEXT STEPS</a:t>
+              <a:t>MULTI-AGENT DECISION ENGINE</a:t>
             </a:r>
             <a:endParaRPr lang="en-US" sz="1100" dirty="0"/>
           </a:p>
@@ -4611,347 +5341,143 @@
       </p:sp>
       <p:sp>
         <p:nvSpPr>
-          <p:cNvPr id="4" name="Text 2"/>
-          <p:cNvSpPr/>
-          <p:nvPr/>
-        </p:nvSpPr>
-        <p:spPr>
-          <a:xfrm>
-            <a:off x="457200" y="2286000"/>
-            <a:ext cx="10972800" cy="731520"/>
-          </a:xfrm>
-          <a:prstGeom prst="rect">
-            <a:avLst/>
-          </a:prstGeom>
-          <a:noFill/>
-          <a:ln/>
-        </p:spPr>
-        <p:txBody>
-          <a:bodyPr wrap="square" rtlCol="0" anchor="ctr"/>
-          <a:lstStyle/>
-          <a:p>
-            <a:pPr algn="ctr" indent="0" marL="0">
-              <a:buNone/>
-            </a:pPr>
-            <a:r>
-              <a:rPr lang="en-US" sz="3600" b="1" dirty="0">
+          <p:cNvPr id="5" name="Text 3"/>
+          <p:cNvSpPr/>
+          <p:nvPr/>
+        </p:nvSpPr>
+        <p:spPr>
+          <a:xfrm>
+            <a:off x="731520" y="1554480"/>
+            <a:ext cx="4114800" cy="914400"/>
+          </a:xfrm>
+          <a:prstGeom prst="rect">
+            <a:avLst/>
+          </a:prstGeom>
+          <a:noFill/>
+          <a:ln/>
+        </p:spPr>
+        <p:txBody>
+          <a:bodyPr wrap="square" rtlCol="0" anchor="ctr"/>
+          <a:lstStyle/>
+          <a:p>
+            <a:pPr indent="0" marL="0">
+              <a:buNone/>
+            </a:pPr>
+            <a:r>
+              <a:rPr lang="en-US" sz="2000" b="1" dirty="0">
                 <a:solidFill>
                   <a:srgbClr val="FFFFFF"/>
                 </a:solidFill>
               </a:rPr>
-              <a:t>Let’s Talk</a:t>
-            </a:r>
-            <a:endParaRPr lang="en-US" sz="3600" dirty="0"/>
-          </a:p>
-        </p:txBody>
-      </p:sp>
-      <p:sp>
-        <p:nvSpPr>
-          <p:cNvPr id="5" name="Text 3"/>
-          <p:cNvSpPr/>
-          <p:nvPr/>
-        </p:nvSpPr>
-        <p:spPr>
-          <a:xfrm>
-            <a:off x="1371600" y="3200400"/>
-            <a:ext cx="9144000" cy="457200"/>
-          </a:xfrm>
-          <a:prstGeom prst="rect">
-            <a:avLst/>
-          </a:prstGeom>
-          <a:noFill/>
-          <a:ln/>
-        </p:spPr>
-        <p:txBody>
-          <a:bodyPr wrap="square" rtlCol="0" anchor="ctr"/>
-          <a:lstStyle/>
-          <a:p>
-            <a:pPr algn="ctr" indent="0" marL="0">
-              <a:buNone/>
-            </a:pPr>
-            <a:r>
-              <a:rPr lang="en-US" sz="1400" dirty="0">
-                <a:solidFill>
-                  <a:srgbClr val="8B8FA3"/>
-                </a:solidFill>
-              </a:rPr>
-              <a:t>AI Governance for Regulated Financial Institutions</a:t>
-            </a:r>
-            <a:endParaRPr lang="en-US" sz="1400" dirty="0"/>
-          </a:p>
-        </p:txBody>
-      </p:sp>
-      <p:sp>
-        <p:nvSpPr>
-          <p:cNvPr id="6" name="Shape 4"/>
-          <p:cNvSpPr/>
-          <p:nvPr/>
-        </p:nvSpPr>
-        <p:spPr>
-          <a:xfrm>
-            <a:off x="2286000" y="3931920"/>
-            <a:ext cx="1828800" cy="457200"/>
-          </a:xfrm>
-          <a:prstGeom prst="roundRect">
-            <a:avLst>
-              <a:gd name="adj" fmla="val 10000"/>
-            </a:avLst>
-          </a:prstGeom>
-          <a:solidFill>
-            <a:srgbClr val="141825"/>
-          </a:solidFill>
-          <a:ln/>
-        </p:spPr>
-      </p:sp>
-      <p:sp>
-        <p:nvSpPr>
-          <p:cNvPr id="7" name="Text 5"/>
-          <p:cNvSpPr/>
-          <p:nvPr/>
-        </p:nvSpPr>
-        <p:spPr>
-          <a:xfrm>
-            <a:off x="2286000" y="3931920"/>
-            <a:ext cx="1828800" cy="457200"/>
-          </a:xfrm>
-          <a:prstGeom prst="rect">
-            <a:avLst/>
-          </a:prstGeom>
-          <a:noFill/>
-          <a:ln/>
-        </p:spPr>
-        <p:txBody>
-          <a:bodyPr wrap="square" rtlCol="0" anchor="ctr"/>
-          <a:lstStyle/>
-          <a:p>
-            <a:pPr algn="ctr" indent="0" marL="0">
-              <a:buNone/>
-            </a:pPr>
-            <a:r>
-              <a:rPr lang="en-US" sz="1100" b="1" dirty="0">
-                <a:solidFill>
-                  <a:srgbClr val="D4AF37"/>
-                </a:solidFill>
-              </a:rPr>
-              <a:t>Schedule Deep Dive</a:t>
+              <a:t>Decisions Made by Specialized AI Agents</a:t>
+            </a:r>
+            <a:endParaRPr lang="en-US" sz="2000" dirty="0"/>
+          </a:p>
+        </p:txBody>
+      </p:sp>
+      <p:sp>
+        <p:nvSpPr>
+          <p:cNvPr id="6" name="Text 4"/>
+          <p:cNvSpPr/>
+          <p:nvPr/>
+        </p:nvSpPr>
+        <p:spPr>
+          <a:xfrm>
+            <a:off x="731520" y="2743200"/>
+            <a:ext cx="4114800" cy="3200400"/>
+          </a:xfrm>
+          <a:prstGeom prst="rect">
+            <a:avLst/>
+          </a:prstGeom>
+          <a:noFill/>
+          <a:ln/>
+        </p:spPr>
+        <p:txBody>
+          <a:bodyPr wrap="square" rtlCol="0" anchor="t"/>
+          <a:lstStyle/>
+          <a:p>
+            <a:pPr marL="342900" indent="-342900">
+              <a:lnSpc>
+                <a:spcPct val="150000"/>
+              </a:lnSpc>
+              <a:buSzPct val="100000"/>
+              <a:buChar char="→"/>
+            </a:pPr>
+            <a:r>
+              <a:rPr lang="en-US" sz="1100" dirty="0">
+                <a:solidFill>
+                  <a:srgbClr val="8B8FA3"/>
+                </a:solidFill>
+              </a:rPr>
+              <a:t>Role-specific agents: CFO, CISO, Legal, Strategy, Risk</a:t>
             </a:r>
             <a:endParaRPr lang="en-US" sz="1100" dirty="0"/>
           </a:p>
-        </p:txBody>
-      </p:sp>
-      <p:sp>
-        <p:nvSpPr>
-          <p:cNvPr id="8" name="Shape 6"/>
-          <p:cNvSpPr/>
-          <p:nvPr/>
-        </p:nvSpPr>
-        <p:spPr>
-          <a:xfrm>
-            <a:off x="4297680" y="3931920"/>
-            <a:ext cx="1828800" cy="457200"/>
-          </a:xfrm>
-          <a:prstGeom prst="roundRect">
-            <a:avLst>
-              <a:gd name="adj" fmla="val 10000"/>
-            </a:avLst>
-          </a:prstGeom>
-          <a:solidFill>
-            <a:srgbClr val="141825"/>
-          </a:solidFill>
-          <a:ln/>
-        </p:spPr>
-      </p:sp>
-      <p:sp>
-        <p:nvSpPr>
-          <p:cNvPr id="9" name="Text 7"/>
-          <p:cNvSpPr/>
-          <p:nvPr/>
-        </p:nvSpPr>
-        <p:spPr>
-          <a:xfrm>
-            <a:off x="4297680" y="3931920"/>
-            <a:ext cx="1828800" cy="457200"/>
-          </a:xfrm>
-          <a:prstGeom prst="rect">
-            <a:avLst/>
-          </a:prstGeom>
-          <a:noFill/>
-          <a:ln/>
-        </p:spPr>
-        <p:txBody>
-          <a:bodyPr wrap="square" rtlCol="0" anchor="ctr"/>
-          <a:lstStyle/>
-          <a:p>
-            <a:pPr algn="ctr" indent="0" marL="0">
-              <a:buNone/>
-            </a:pPr>
-            <a:r>
-              <a:rPr lang="en-US" sz="1100" b="1" dirty="0">
-                <a:solidFill>
-                  <a:srgbClr val="D4AF37"/>
-                </a:solidFill>
-              </a:rPr>
-              <a:t>Technical Demo</a:t>
+          <a:p>
+            <a:pPr marL="342900" indent="-342900">
+              <a:lnSpc>
+                <a:spcPct val="150000"/>
+              </a:lnSpc>
+              <a:buSzPct val="100000"/>
+              <a:buChar char="→"/>
+            </a:pPr>
+            <a:r>
+              <a:rPr lang="en-US" sz="1100" dirty="0">
+                <a:solidFill>
+                  <a:srgbClr val="8B8FA3"/>
+                </a:solidFill>
+              </a:rPr>
+              <a:t>Confidence scores and reasoning — dissent preserved</a:t>
             </a:r>
             <a:endParaRPr lang="en-US" sz="1100" dirty="0"/>
           </a:p>
-        </p:txBody>
-      </p:sp>
-      <p:sp>
-        <p:nvSpPr>
-          <p:cNvPr id="10" name="Shape 8"/>
-          <p:cNvSpPr/>
-          <p:nvPr/>
-        </p:nvSpPr>
-        <p:spPr>
-          <a:xfrm>
-            <a:off x="6309360" y="3931920"/>
-            <a:ext cx="1828800" cy="457200"/>
-          </a:xfrm>
-          <a:prstGeom prst="roundRect">
-            <a:avLst>
-              <a:gd name="adj" fmla="val 10000"/>
-            </a:avLst>
-          </a:prstGeom>
-          <a:solidFill>
-            <a:srgbClr val="141825"/>
-          </a:solidFill>
-          <a:ln/>
-        </p:spPr>
-      </p:sp>
-      <p:sp>
-        <p:nvSpPr>
-          <p:cNvPr id="11" name="Text 9"/>
-          <p:cNvSpPr/>
-          <p:nvPr/>
-        </p:nvSpPr>
-        <p:spPr>
-          <a:xfrm>
-            <a:off x="6309360" y="3931920"/>
-            <a:ext cx="1828800" cy="457200"/>
-          </a:xfrm>
-          <a:prstGeom prst="rect">
-            <a:avLst/>
-          </a:prstGeom>
-          <a:noFill/>
-          <a:ln/>
-        </p:spPr>
-        <p:txBody>
-          <a:bodyPr wrap="square" rtlCol="0" anchor="ctr"/>
-          <a:lstStyle/>
-          <a:p>
-            <a:pPr algn="ctr" indent="0" marL="0">
-              <a:buNone/>
-            </a:pPr>
-            <a:r>
-              <a:rPr lang="en-US" sz="1100" b="1" dirty="0">
-                <a:solidFill>
-                  <a:srgbClr val="D4AF37"/>
-                </a:solidFill>
-              </a:rPr>
-              <a:t>Data Room Access</a:t>
+          <a:p>
+            <a:pPr marL="342900" indent="-342900">
+              <a:lnSpc>
+                <a:spcPct val="150000"/>
+              </a:lnSpc>
+              <a:buSzPct val="100000"/>
+              <a:buChar char="→"/>
+            </a:pPr>
+            <a:r>
+              <a:rPr lang="en-US" sz="1100" dirty="0">
+                <a:solidFill>
+                  <a:srgbClr val="8B8FA3"/>
+                </a:solidFill>
+              </a:rPr>
+              <a:t>War Room, Governed, and Quick Brief modes</a:t>
             </a:r>
             <a:endParaRPr lang="en-US" sz="1100" dirty="0"/>
           </a:p>
         </p:txBody>
       </p:sp>
-      <p:sp>
-        <p:nvSpPr>
-          <p:cNvPr id="12" name="Shape 10"/>
-          <p:cNvSpPr/>
-          <p:nvPr/>
-        </p:nvSpPr>
-        <p:spPr>
-          <a:xfrm>
-            <a:off x="8321040" y="3931920"/>
-            <a:ext cx="1828800" cy="457200"/>
-          </a:xfrm>
-          <a:prstGeom prst="roundRect">
-            <a:avLst>
-              <a:gd name="adj" fmla="val 10000"/>
-            </a:avLst>
-          </a:prstGeom>
-          <a:solidFill>
-            <a:srgbClr val="D4AF37"/>
-          </a:solidFill>
-          <a:ln/>
-        </p:spPr>
-      </p:sp>
-      <p:sp>
-        <p:nvSpPr>
-          <p:cNvPr id="13" name="Text 11"/>
-          <p:cNvSpPr/>
-          <p:nvPr/>
-        </p:nvSpPr>
-        <p:spPr>
-          <a:xfrm>
-            <a:off x="8321040" y="3931920"/>
-            <a:ext cx="1828800" cy="457200"/>
-          </a:xfrm>
-          <a:prstGeom prst="rect">
-            <a:avLst/>
-          </a:prstGeom>
-          <a:noFill/>
-          <a:ln/>
-        </p:spPr>
-        <p:txBody>
-          <a:bodyPr wrap="square" rtlCol="0" anchor="ctr"/>
-          <a:lstStyle/>
-          <a:p>
-            <a:pPr algn="ctr" indent="0" marL="0">
-              <a:buNone/>
-            </a:pPr>
-            <a:r>
-              <a:rPr lang="en-US" sz="1100" b="1" dirty="0">
-                <a:solidFill>
-                  <a:srgbClr val="0A0E1A"/>
-                </a:solidFill>
-              </a:rPr>
-              <a:t>Try Live Demo →</a:t>
-            </a:r>
-            <a:endParaRPr lang="en-US" sz="1100" dirty="0"/>
-          </a:p>
-        </p:txBody>
-      </p:sp>
-      <p:sp>
-        <p:nvSpPr>
-          <p:cNvPr id="14" name="Text 12"/>
-          <p:cNvSpPr/>
-          <p:nvPr/>
-        </p:nvSpPr>
-        <p:spPr>
-          <a:xfrm>
-            <a:off x="1828800" y="5029200"/>
-            <a:ext cx="8229600" cy="365760"/>
-          </a:xfrm>
-          <a:prstGeom prst="rect">
-            <a:avLst/>
-          </a:prstGeom>
-          <a:noFill/>
-          <a:ln/>
-        </p:spPr>
-        <p:txBody>
-          <a:bodyPr wrap="square" rtlCol="0" anchor="ctr"/>
-          <a:lstStyle/>
-          <a:p>
-            <a:pPr algn="ctr" indent="0" marL="0">
-              <a:buNone/>
-            </a:pPr>
-            <a:r>
-              <a:rPr lang="en-US" sz="1200" dirty="0">
-                <a:solidFill>
-                  <a:srgbClr val="8B8FA3"/>
-                </a:solidFill>
-              </a:rPr>
-              <a:t>contact@datacendia.com | datacendia.com</a:t>
-            </a:r>
-            <a:endParaRPr lang="en-US" sz="1200" dirty="0"/>
-          </a:p>
-        </p:txBody>
-      </p:sp>
-      <p:sp>
-        <p:nvSpPr>
-          <p:cNvPr id="15" name="Text 13"/>
+      <p:pic>
+        <p:nvPicPr>
+          <p:cNvPr id="7" name="Image 0" descr="C:\Users\User\datacendia-core\docs\pitch-decks\screenshots\02-council-deliberation.png">    </p:cNvPr>
+          <p:cNvPicPr>
+            <a:picLocks noChangeAspect="1"/>
+          </p:cNvPicPr>
+          <p:nvPr/>
+        </p:nvPicPr>
+        <p:blipFill>
+          <a:blip r:embed="rId1"/>
+          <a:stretch>
+            <a:fillRect/>
+          </a:stretch>
+        </p:blipFill>
+        <p:spPr>
+          <a:xfrm>
+            <a:off x="5303520" y="1097280"/>
+            <a:ext cx="6400800" cy="4846320"/>
+          </a:xfrm>
+          <a:prstGeom prst="ellipse">
+            <a:avLst/>
+          </a:prstGeom>
+        </p:spPr>
+      </p:pic>
+      <p:sp>
+        <p:nvSpPr>
+          <p:cNvPr id="8" name="Text 5"/>
           <p:cNvSpPr/>
           <p:nvPr/>
         </p:nvSpPr>
@@ -4987,7 +5513,355 @@
       </p:sp>
       <p:sp>
         <p:nvSpPr>
-          <p:cNvPr id="16" name="Text 14"/>
+          <p:cNvPr id="9" name="Text 6"/>
+          <p:cNvSpPr/>
+          <p:nvPr/>
+        </p:nvSpPr>
+        <p:spPr>
+          <a:xfrm>
+            <a:off x="8229600" y="6400800"/>
+            <a:ext cx="3657600" cy="274320"/>
+          </a:xfrm>
+          <a:prstGeom prst="rect">
+            <a:avLst/>
+          </a:prstGeom>
+          <a:noFill/>
+          <a:ln/>
+        </p:spPr>
+        <p:txBody>
+          <a:bodyPr wrap="square" rtlCol="0" anchor="ctr"/>
+          <a:lstStyle/>
+          <a:p>
+            <a:pPr algn="r" indent="0" marL="0">
+              <a:buNone/>
+            </a:pPr>
+            <a:r>
+              <a:rPr lang="en-US" sz="800" dirty="0">
+                <a:solidFill>
+                  <a:srgbClr val="8B8FA3"/>
+                </a:solidFill>
+              </a:rPr>
+              <a:t>datacendia.com</a:t>
+            </a:r>
+            <a:endParaRPr lang="en-US" sz="800" dirty="0"/>
+          </a:p>
+        </p:txBody>
+      </p:sp>
+    </p:spTree>
+  </p:cSld>
+  <p:clrMapOvr>
+    <a:masterClrMapping/>
+  </p:clrMapOvr>
+</p:sld>
+</file>
+
+<file path=ppt/slides/slide9.xml><?xml version="1.0" encoding="utf-8"?>
+<p:sld xmlns:a="http://schemas.openxmlformats.org/drawingml/2006/main" xmlns:r="http://schemas.openxmlformats.org/officeDocument/2006/relationships" xmlns:p="http://schemas.openxmlformats.org/presentationml/2006/main">
+  <p:cSld name="Slide 9">
+    <p:bg>
+      <p:bgPr>
+        <a:solidFill>
+          <a:srgbClr val="0A0E1A"/>
+        </a:solidFill>
+      </p:bgPr>
+    </p:bg>
+    <p:spTree>
+      <p:nvGrpSpPr>
+        <p:cNvPr id="1" name=""/>
+        <p:cNvGrpSpPr/>
+        <p:nvPr/>
+      </p:nvGrpSpPr>
+      <p:grpSpPr>
+        <a:xfrm>
+          <a:off x="0" y="0"/>
+          <a:ext cx="0" cy="0"/>
+          <a:chOff x="0" y="0"/>
+          <a:chExt cx="0" cy="0"/>
+        </a:xfrm>
+      </p:grpSpPr>
+      <p:sp>
+        <p:nvSpPr>
+          <p:cNvPr id="2" name="Text 0"/>
+          <p:cNvSpPr/>
+          <p:nvPr/>
+        </p:nvSpPr>
+        <p:spPr>
+          <a:xfrm>
+            <a:off x="457200" y="274320"/>
+            <a:ext cx="2743200" cy="274320"/>
+          </a:xfrm>
+          <a:prstGeom prst="rect">
+            <a:avLst/>
+          </a:prstGeom>
+          <a:noFill/>
+          <a:ln/>
+        </p:spPr>
+        <p:txBody>
+          <a:bodyPr wrap="square" rtlCol="0" anchor="ctr"/>
+          <a:lstStyle/>
+          <a:p>
+            <a:pPr indent="0" marL="0">
+              <a:buNone/>
+            </a:pPr>
+            <a:r>
+              <a:rPr lang="en-US" sz="1000" b="1" dirty="0">
+                <a:solidFill>
+                  <a:srgbClr val="D4AF37"/>
+                </a:solidFill>
+              </a:rPr>
+              <a:t>DATACENDIA</a:t>
+            </a:r>
+            <a:endParaRPr lang="en-US" sz="1000" dirty="0"/>
+          </a:p>
+        </p:txBody>
+      </p:sp>
+      <p:sp>
+        <p:nvSpPr>
+          <p:cNvPr id="3" name="Text 1"/>
+          <p:cNvSpPr/>
+          <p:nvPr/>
+        </p:nvSpPr>
+        <p:spPr>
+          <a:xfrm>
+            <a:off x="8229600" y="274320"/>
+            <a:ext cx="3657600" cy="274320"/>
+          </a:xfrm>
+          <a:prstGeom prst="rect">
+            <a:avLst/>
+          </a:prstGeom>
+          <a:noFill/>
+          <a:ln/>
+        </p:spPr>
+        <p:txBody>
+          <a:bodyPr wrap="square" rtlCol="0" anchor="ctr"/>
+          <a:lstStyle/>
+          <a:p>
+            <a:pPr algn="r" indent="0" marL="0">
+              <a:buNone/>
+            </a:pPr>
+            <a:r>
+              <a:rPr lang="en-US" sz="800" dirty="0">
+                <a:solidFill>
+                  <a:srgbClr val="8B8FA3"/>
+                </a:solidFill>
+              </a:rPr>
+              <a:t>PLATFORM PROOF</a:t>
+            </a:r>
+            <a:endParaRPr lang="en-US" sz="800" dirty="0"/>
+          </a:p>
+        </p:txBody>
+      </p:sp>
+      <p:sp>
+        <p:nvSpPr>
+          <p:cNvPr id="4" name="Text 2"/>
+          <p:cNvSpPr/>
+          <p:nvPr/>
+        </p:nvSpPr>
+        <p:spPr>
+          <a:xfrm>
+            <a:off x="731520" y="1097280"/>
+            <a:ext cx="4114800" cy="274320"/>
+          </a:xfrm>
+          <a:prstGeom prst="rect">
+            <a:avLst/>
+          </a:prstGeom>
+          <a:noFill/>
+          <a:ln/>
+        </p:spPr>
+        <p:txBody>
+          <a:bodyPr wrap="square" rtlCol="0" anchor="ctr"/>
+          <a:lstStyle/>
+          <a:p>
+            <a:pPr indent="0" marL="0">
+              <a:buNone/>
+            </a:pPr>
+            <a:r>
+              <a:rPr lang="en-US" sz="1100" dirty="0">
+                <a:solidFill>
+                  <a:srgbClr val="D4AF37"/>
+                </a:solidFill>
+              </a:rPr>
+              <a:t>DECISION AUDIT TRAIL</a:t>
+            </a:r>
+            <a:endParaRPr lang="en-US" sz="1100" dirty="0"/>
+          </a:p>
+        </p:txBody>
+      </p:sp>
+      <p:sp>
+        <p:nvSpPr>
+          <p:cNvPr id="5" name="Text 3"/>
+          <p:cNvSpPr/>
+          <p:nvPr/>
+        </p:nvSpPr>
+        <p:spPr>
+          <a:xfrm>
+            <a:off x="731520" y="1554480"/>
+            <a:ext cx="4114800" cy="914400"/>
+          </a:xfrm>
+          <a:prstGeom prst="rect">
+            <a:avLst/>
+          </a:prstGeom>
+          <a:noFill/>
+          <a:ln/>
+        </p:spPr>
+        <p:txBody>
+          <a:bodyPr wrap="square" rtlCol="0" anchor="ctr"/>
+          <a:lstStyle/>
+          <a:p>
+            <a:pPr indent="0" marL="0">
+              <a:buNone/>
+            </a:pPr>
+            <a:r>
+              <a:rPr lang="en-US" sz="2000" b="1" dirty="0">
+                <a:solidFill>
+                  <a:srgbClr val="FFFFFF"/>
+                </a:solidFill>
+              </a:rPr>
+              <a:t>Every Decision Tracked with Full Evidence Chain</a:t>
+            </a:r>
+            <a:endParaRPr lang="en-US" sz="2000" dirty="0"/>
+          </a:p>
+        </p:txBody>
+      </p:sp>
+      <p:sp>
+        <p:nvSpPr>
+          <p:cNvPr id="6" name="Text 4"/>
+          <p:cNvSpPr/>
+          <p:nvPr/>
+        </p:nvSpPr>
+        <p:spPr>
+          <a:xfrm>
+            <a:off x="731520" y="2743200"/>
+            <a:ext cx="4114800" cy="3200400"/>
+          </a:xfrm>
+          <a:prstGeom prst="rect">
+            <a:avLst/>
+          </a:prstGeom>
+          <a:noFill/>
+          <a:ln/>
+        </p:spPr>
+        <p:txBody>
+          <a:bodyPr wrap="square" rtlCol="0" anchor="t"/>
+          <a:lstStyle/>
+          <a:p>
+            <a:pPr marL="342900" indent="-342900">
+              <a:lnSpc>
+                <a:spcPct val="150000"/>
+              </a:lnSpc>
+              <a:buSzPct val="100000"/>
+              <a:buChar char="→"/>
+            </a:pPr>
+            <a:r>
+              <a:rPr lang="en-US" sz="1100" dirty="0">
+                <a:solidFill>
+                  <a:srgbClr val="8B8FA3"/>
+                </a:solidFill>
+              </a:rPr>
+              <a:t>Complete searchable decision history</a:t>
+            </a:r>
+            <a:endParaRPr lang="en-US" sz="1100" dirty="0"/>
+          </a:p>
+          <a:p>
+            <a:pPr marL="342900" indent="-342900">
+              <a:lnSpc>
+                <a:spcPct val="150000"/>
+              </a:lnSpc>
+              <a:buSzPct val="100000"/>
+              <a:buChar char="→"/>
+            </a:pPr>
+            <a:r>
+              <a:rPr lang="en-US" sz="1100" dirty="0">
+                <a:solidFill>
+                  <a:srgbClr val="8B8FA3"/>
+                </a:solidFill>
+              </a:rPr>
+              <a:t>Full deliberation records linked to each decision</a:t>
+            </a:r>
+            <a:endParaRPr lang="en-US" sz="1100" dirty="0"/>
+          </a:p>
+          <a:p>
+            <a:pPr marL="342900" indent="-342900">
+              <a:lnSpc>
+                <a:spcPct val="150000"/>
+              </a:lnSpc>
+              <a:buSzPct val="100000"/>
+              <a:buChar char="→"/>
+            </a:pPr>
+            <a:r>
+              <a:rPr lang="en-US" sz="1100" dirty="0">
+                <a:solidFill>
+                  <a:srgbClr val="8B8FA3"/>
+                </a:solidFill>
+              </a:rPr>
+              <a:t>Trace any decision back to evidence in seconds</a:t>
+            </a:r>
+            <a:endParaRPr lang="en-US" sz="1100" dirty="0"/>
+          </a:p>
+        </p:txBody>
+      </p:sp>
+      <p:pic>
+        <p:nvPicPr>
+          <p:cNvPr id="7" name="Image 0" descr="C:\Users\User\datacendia-core\docs\pitch-decks\screenshots\05-decisions.png">    </p:cNvPr>
+          <p:cNvPicPr>
+            <a:picLocks noChangeAspect="1"/>
+          </p:cNvPicPr>
+          <p:nvPr/>
+        </p:nvPicPr>
+        <p:blipFill>
+          <a:blip r:embed="rId1"/>
+          <a:stretch>
+            <a:fillRect/>
+          </a:stretch>
+        </p:blipFill>
+        <p:spPr>
+          <a:xfrm>
+            <a:off x="5303520" y="1097280"/>
+            <a:ext cx="6400800" cy="4846320"/>
+          </a:xfrm>
+          <a:prstGeom prst="ellipse">
+            <a:avLst/>
+          </a:prstGeom>
+        </p:spPr>
+      </p:pic>
+      <p:sp>
+        <p:nvSpPr>
+          <p:cNvPr id="8" name="Text 5"/>
+          <p:cNvSpPr/>
+          <p:nvPr/>
+        </p:nvSpPr>
+        <p:spPr>
+          <a:xfrm>
+            <a:off x="457200" y="6400800"/>
+            <a:ext cx="3657600" cy="274320"/>
+          </a:xfrm>
+          <a:prstGeom prst="rect">
+            <a:avLst/>
+          </a:prstGeom>
+          <a:noFill/>
+          <a:ln/>
+        </p:spPr>
+        <p:txBody>
+          <a:bodyPr wrap="square" rtlCol="0" anchor="ctr"/>
+          <a:lstStyle/>
+          <a:p>
+            <a:pPr indent="0" marL="0">
+              <a:buNone/>
+            </a:pPr>
+            <a:r>
+              <a:rPr lang="en-US" sz="800" dirty="0">
+                <a:solidFill>
+                  <a:srgbClr val="8B8FA3"/>
+                </a:solidFill>
+              </a:rPr>
+              <a:t>© 2024-2026 Datacendia, LLC</a:t>
+            </a:r>
+            <a:endParaRPr lang="en-US" sz="800" dirty="0"/>
+          </a:p>
+        </p:txBody>
+      </p:sp>
+      <p:sp>
+        <p:nvSpPr>
+          <p:cNvPr id="9" name="Text 6"/>
           <p:cNvSpPr/>
           <p:nvPr/>
         </p:nvSpPr>

</xml_diff>